<commit_message>
Løsningsforslag til hjemmeopgave, lektion 12
</commit_message>
<xml_diff>
--- a/lektion_12/E26TDIN-12 Hjemmeopgave.pptx
+++ b/lektion_12/E26TDIN-12 Hjemmeopgave.pptx
@@ -129,7 +129,7 @@
   <pc:docChgLst>
     <pc:chgData name="Aksel Boje Christensen (lektor – akch@eaaa.dk)" userId="6fa706e3-6588-4f43-8f4d-12a9cabadb77" providerId="ADAL" clId="{2C3B4BF6-3722-4112-A680-F85E416198AA}"/>
     <pc:docChg chg="undo redo custSel addSld delSld modSld sldOrd">
-      <pc:chgData name="Aksel Boje Christensen (lektor – akch@eaaa.dk)" userId="6fa706e3-6588-4f43-8f4d-12a9cabadb77" providerId="ADAL" clId="{2C3B4BF6-3722-4112-A680-F85E416198AA}" dt="2026-10-26T06:54:19.921" v="34337" actId="20577"/>
+      <pc:chgData name="Aksel Boje Christensen (lektor – akch@eaaa.dk)" userId="6fa706e3-6588-4f43-8f4d-12a9cabadb77" providerId="ADAL" clId="{2C3B4BF6-3722-4112-A680-F85E416198AA}" dt="2026-10-26T07:04:29.039" v="34374" actId="20577"/>
       <pc:docMkLst>
         <pc:docMk/>
       </pc:docMkLst>
@@ -388,7 +388,7 @@
         </pc:sldMkLst>
       </pc:sldChg>
       <pc:sldChg chg="addSp delSp modSp new mod ord modClrScheme chgLayout">
-        <pc:chgData name="Aksel Boje Christensen (lektor – akch@eaaa.dk)" userId="6fa706e3-6588-4f43-8f4d-12a9cabadb77" providerId="ADAL" clId="{2C3B4BF6-3722-4112-A680-F85E416198AA}" dt="2026-10-26T06:54:19.921" v="34337" actId="20577"/>
+        <pc:chgData name="Aksel Boje Christensen (lektor – akch@eaaa.dk)" userId="6fa706e3-6588-4f43-8f4d-12a9cabadb77" providerId="ADAL" clId="{2C3B4BF6-3722-4112-A680-F85E416198AA}" dt="2026-10-26T07:04:29.039" v="34374" actId="20577"/>
         <pc:sldMkLst>
           <pc:docMk/>
           <pc:sldMk cId="865107493" sldId="882"/>
@@ -426,7 +426,7 @@
           </ac:spMkLst>
         </pc:spChg>
         <pc:spChg chg="add mod ord">
-          <ac:chgData name="Aksel Boje Christensen (lektor – akch@eaaa.dk)" userId="6fa706e3-6588-4f43-8f4d-12a9cabadb77" providerId="ADAL" clId="{2C3B4BF6-3722-4112-A680-F85E416198AA}" dt="2026-10-26T06:54:19.921" v="34337" actId="20577"/>
+          <ac:chgData name="Aksel Boje Christensen (lektor – akch@eaaa.dk)" userId="6fa706e3-6588-4f43-8f4d-12a9cabadb77" providerId="ADAL" clId="{2C3B4BF6-3722-4112-A680-F85E416198AA}" dt="2026-10-26T07:04:29.039" v="34374" actId="20577"/>
           <ac:spMkLst>
             <pc:docMk/>
             <pc:sldMk cId="865107493" sldId="882"/>
@@ -15116,10 +15116,41 @@
               <a:t>periode</a:t>
             </a:r>
             <a:r>
+              <a:rPr lang="en-US" sz="1400" dirty="0">
+                <a:latin typeface="+mn-lt"/>
+              </a:rPr>
+              <a:t>.</a:t>
+            </a:r>
+          </a:p>
+          <a:p>
+            <a:endParaRPr lang="en-US" sz="1400" dirty="0">
+              <a:latin typeface="+mn-lt"/>
+            </a:endParaRPr>
+          </a:p>
+          <a:p>
+            <a:r>
+              <a:rPr lang="en-US" sz="1400" dirty="0" err="1">
+                <a:latin typeface="+mn-lt"/>
+              </a:rPr>
+              <a:t>Løsningsforslag</a:t>
+            </a:r>
+            <a:r>
+              <a:rPr lang="en-US" sz="1400" dirty="0">
+                <a:latin typeface="+mn-lt"/>
+              </a:rPr>
+              <a:t> </a:t>
+            </a:r>
+            <a:r>
               <a:rPr lang="en-US" sz="1400">
                 <a:latin typeface="+mn-lt"/>
               </a:rPr>
-              <a:t>.</a:t>
+              <a:t>i </a:t>
+            </a:r>
+            <a:r>
+              <a:rPr lang="en-US" sz="1400" dirty="0" err="1">
+                <a:latin typeface="+mn-lt"/>
+              </a:rPr>
+              <a:t>mappen</a:t>
             </a:r>
             <a:endParaRPr lang="da-DK" sz="1400" dirty="0">
               <a:latin typeface="+mn-lt"/>
@@ -15692,15 +15723,6 @@
 </file>
 
 <file path=customXml/item1.xml><?xml version="1.0" encoding="utf-8"?>
-<?mso-contentType ?>
-<FormTemplates xmlns="http://schemas.microsoft.com/sharepoint/v3/contenttype/forms">
-  <Display>DocumentLibraryForm</Display>
-  <Edit>DocumentLibraryForm</Edit>
-  <New>DocumentLibraryForm</New>
-</FormTemplates>
-</file>
-
-<file path=customXml/item2.xml><?xml version="1.0" encoding="utf-8"?>
 <ct:contentTypeSchema xmlns:ct="http://schemas.microsoft.com/office/2006/metadata/contentType" xmlns:ma="http://schemas.microsoft.com/office/2006/metadata/properties/metaAttributes" ct:_="" ma:_="" ma:contentTypeName="Dokument" ma:contentTypeID="0x010100227D6D28A4E3024898CEDF6BCEE0CA75" ma:contentTypeVersion="15" ma:contentTypeDescription="Opret et nyt dokument." ma:contentTypeScope="" ma:versionID="375c950afed99906638e8c93df33b113">
   <xsd:schema xmlns:xsd="http://www.w3.org/2001/XMLSchema" xmlns:xs="http://www.w3.org/2001/XMLSchema" xmlns:p="http://schemas.microsoft.com/office/2006/metadata/properties" xmlns:ns2="e7042a3e-177d-4746-859a-bfd76803216a" xmlns:ns3="9c595732-8be9-4d02-a63c-8290171736ff" targetNamespace="http://schemas.microsoft.com/office/2006/metadata/properties" ma:root="true" ma:fieldsID="c16db8e41df52ff3fd5a61846f102f0b" ns2:_="" ns3:_="">
     <xsd:import namespace="e7042a3e-177d-4746-859a-bfd76803216a"/>
@@ -15929,6 +15951,15 @@
 </ct:contentTypeSchema>
 </file>
 
+<file path=customXml/item2.xml><?xml version="1.0" encoding="utf-8"?>
+<?mso-contentType ?>
+<FormTemplates xmlns="http://schemas.microsoft.com/sharepoint/v3/contenttype/forms">
+  <Display>DocumentLibraryForm</Display>
+  <Edit>DocumentLibraryForm</Edit>
+  <New>DocumentLibraryForm</New>
+</FormTemplates>
+</file>
+
 <file path=customXml/item3.xml><?xml version="1.0" encoding="utf-8"?>
 <p:properties xmlns:p="http://schemas.microsoft.com/office/2006/metadata/properties" xmlns:xsi="http://www.w3.org/2001/XMLSchema-instance" xmlns:pc="http://schemas.microsoft.com/office/infopath/2007/PartnerControls">
   <documentManagement>
@@ -15941,14 +15972,6 @@
 </file>
 
 <file path=customXml/itemProps1.xml><?xml version="1.0" encoding="utf-8"?>
-<ds:datastoreItem xmlns:ds="http://schemas.openxmlformats.org/officeDocument/2006/customXml" ds:itemID="{A355CE3D-A327-42EE-A10E-76F0E86EB4B8}">
-  <ds:schemaRefs>
-    <ds:schemaRef ds:uri="http://schemas.microsoft.com/sharepoint/v3/contenttype/forms"/>
-  </ds:schemaRefs>
-</ds:datastoreItem>
-</file>
-
-<file path=customXml/itemProps2.xml><?xml version="1.0" encoding="utf-8"?>
 <ds:datastoreItem xmlns:ds="http://schemas.openxmlformats.org/officeDocument/2006/customXml" ds:itemID="{61275A44-7BB9-4E74-8416-46CA0F91BB94}">
   <ds:schemaRefs>
     <ds:schemaRef ds:uri="http://schemas.microsoft.com/office/2006/metadata/contentType"/>
@@ -15963,6 +15986,14 @@
     <ds:schemaRef ds:uri="http://purl.org/dc/elements/1.1/"/>
     <ds:schemaRef ds:uri="http://purl.org/dc/terms/"/>
     <ds:schemaRef ds:uri="http://schemas.microsoft.com/internal/obd"/>
+  </ds:schemaRefs>
+</ds:datastoreItem>
+</file>
+
+<file path=customXml/itemProps2.xml><?xml version="1.0" encoding="utf-8"?>
+<ds:datastoreItem xmlns:ds="http://schemas.openxmlformats.org/officeDocument/2006/customXml" ds:itemID="{A355CE3D-A327-42EE-A10E-76F0E86EB4B8}">
+  <ds:schemaRefs>
+    <ds:schemaRef ds:uri="http://schemas.microsoft.com/sharepoint/v3/contenttype/forms"/>
   </ds:schemaRefs>
 </ds:datastoreItem>
 </file>

</xml_diff>